<commit_message>
Clarify 10 vs 22 languages stat on feasibility slide
Slide 4's UIDAI proof point (10 languages, PIB/MeitY 2025) and slide 2's
language-menu figure (22 languages, Sarvam model capacity) are both correct
but refer to different things. Relabelled the stat '10 of 22 languages' and
reworded the body text so the two numbers don't read as a contradiction.

Co-Authored-By: Claude Sonnet 5 <noreply@anthropic.com>
Claude-Session: https://claude.ai/code/session_01XpLCUSjmNpNxHJ2vYpsyUF
</commit_message>
<xml_diff>
--- a/sih-26097/SkillCall_SIH26097_Cognify.pptx
+++ b/sih-26097/SkillCall_SIH26097_Cognify.pptx
@@ -771,7 +771,7 @@
           <a:p>
             <a:r>
               <a:rPr lang="en-US" dirty="0"/>
-              <a:t>Feasibility: UIDAI–Sarvam (10 languages), Kilkari (1.2 million calls/day), Voice of India benchmark (≤20% WER). Cost: ₹37–83 per completed profile; the funnel and working are shown in the table. Viability: ₹0.9–1.7 crore per state per year = 0.04–0.08% of the PM-AJAY budget. Risks and mitigations in the bottom rows.</a:t>
+              <a:t>Feasibility: UIDAI–Sarvam (live today in 10 of Sarvam's 22 Indian languages; SkillCall targets all 22 over time), Kilkari (1.2 million calls/day), Voice of India benchmark (≤20% WER). Cost: ₹37–83 per completed profile; the funnel and working are shown in the table. Viability: ₹0.9–1.7 crore per state per year = 0.04–0.08% of the PM-AJAY budget. Risks and mitigations in the bottom rows.</a:t>
             </a:r>
             <a:endParaRPr lang="en-US" dirty="0"/>
           </a:p>
@@ -11930,7 +11930,7 @@
                 <a:ea typeface="Calibri" pitchFamily="34" charset="-122"/>
                 <a:cs typeface="Calibri" pitchFamily="34" charset="-120"/>
               </a:rPr>
-              <a:t>10 languages</a:t>
+              <a:t>10 of 22 languages</a:t>
             </a:r>
             <a:endParaRPr lang="en-US" sz="1200" dirty="0"/>
           </a:p>
@@ -11969,7 +11969,7 @@
                 <a:ea typeface="Calibri" pitchFamily="34" charset="-122"/>
                 <a:cs typeface="Calibri" pitchFamily="34" charset="-120"/>
               </a:rPr>
-              <a:t>UIDAI already runs Sarvam's voice AI for Aadhaar — on-premise, air-gapped.</a:t>
+              <a:t>UIDAI already runs Sarvam's voice AI for Aadhaar in 10 of its 22 Indian languages — on-premise, air-gapped.</a:t>
             </a:r>
             <a:endParaRPr lang="en-US" sz="690" dirty="0"/>
           </a:p>

</xml_diff>

<commit_message>
Reword the affordability card as '1% more per person'
Replaces the ratio phrasing ('under Rs 1 in every Rs 100'), which needed
mental arithmetic to parse, with the comparison it stands for: the
government already spends Rs 60,700 on one beneficiary, and SkillCall
adds Rs 220-420 on top of that - under 1% - so that the Rs 60,700 goes
to the right course. Same verified figures, clearer wording.

Co-Authored-By: Claude Opus 5 <noreply@anthropic.com>
Claude-Session: https://claude.ai/code/session_01XpLCUSjmNpNxHJ2vYpsyUF
</commit_message>
<xml_diff>
--- a/sih-26097/SkillCall_SIH26097_Cognify.pptx
+++ b/sih-26097/SkillCall_SIH26097_Cognify.pptx
@@ -14233,7 +14233,7 @@
                 <a:ea typeface="Calibri" pitchFamily="34" charset="-122"/>
                 <a:cs typeface="Calibri" pitchFamily="34" charset="-120"/>
               </a:rPr>
-              <a:t>less than ₹1 of every ₹100 it already spends</a:t>
+              <a:t>we add ~1% to what is already spent</a:t>
             </a:r>
             <a:endParaRPr lang="en-US" sz="850" dirty="0"/>
           </a:p>
@@ -14469,7 +14469,7 @@
                 <a:ea typeface="Calibri" pitchFamily="34" charset="-122"/>
                 <a:cs typeface="Calibri" pitchFamily="34" charset="-120"/>
               </a:rPr>
-              <a:t>Under ₹1 in every ₹100  </a:t>
+              <a:t>Only 1% more per person  </a:t>
             </a:r>
             <a:r>
               <a:rPr lang="en-US" sz="650" b="1" dirty="0">
@@ -14480,7 +14480,7 @@
                 <a:ea typeface="Calibri" pitchFamily="34" charset="-122"/>
                 <a:cs typeface="Calibri" pitchFamily="34" charset="-120"/>
               </a:rPr>
-              <a:t>of what each beneficiary already gets</a:t>
+              <a:t>and the other 99% stops being wasted</a:t>
             </a:r>
             <a:r>
               <a:rPr lang="en-US" sz="630" dirty="0">
@@ -14503,7 +14503,7 @@
                 <a:ea typeface="Calibri" pitchFamily="34" charset="-122"/>
                 <a:cs typeface="Calibri" pitchFamily="34" charset="-120"/>
               </a:rPr>
-              <a:t>≈ ₹220–420 per beneficiary vs ≈ </a:t>
+              <a:t>The govt already spends </a:t>
             </a:r>
             <a:r>
               <a:rPr lang="en-US" sz="630" b="1" dirty="0">
@@ -14525,7 +14525,51 @@
                 <a:ea typeface="Calibri" pitchFamily="34" charset="-122"/>
                 <a:cs typeface="Calibri" pitchFamily="34" charset="-120"/>
               </a:rPr>
-              <a:t> average GIA support.</a:t>
+              <a:t> on one beneficiary. SkillCall costs </a:t>
+            </a:r>
+            <a:r>
+              <a:rPr lang="en-US" sz="630" b="1" dirty="0">
+                <a:solidFill>
+                  <a:srgbClr val="1F9D63"/>
+                </a:solidFill>
+                <a:latin typeface="Calibri" pitchFamily="34" charset="0"/>
+                <a:ea typeface="Calibri" pitchFamily="34" charset="-122"/>
+                <a:cs typeface="Calibri" pitchFamily="34" charset="-120"/>
+              </a:rPr>
+              <a:t>₹220–420</a:t>
+            </a:r>
+            <a:r>
+              <a:rPr lang="en-US" sz="630" dirty="0">
+                <a:solidFill>
+                  <a:srgbClr val="1F2937"/>
+                </a:solidFill>
+                <a:latin typeface="Calibri" pitchFamily="34" charset="0"/>
+                <a:ea typeface="Calibri" pitchFamily="34" charset="-122"/>
+                <a:cs typeface="Calibri" pitchFamily="34" charset="-120"/>
+              </a:rPr>
+              <a:t> more — </a:t>
+            </a:r>
+            <a:r>
+              <a:rPr lang="en-US" sz="630" b="1" dirty="0">
+                <a:solidFill>
+                  <a:srgbClr val="1F9D63"/>
+                </a:solidFill>
+                <a:latin typeface="Calibri" pitchFamily="34" charset="0"/>
+                <a:ea typeface="Calibri" pitchFamily="34" charset="-122"/>
+                <a:cs typeface="Calibri" pitchFamily="34" charset="-120"/>
+              </a:rPr>
+              <a:t>under 1%</a:t>
+            </a:r>
+            <a:r>
+              <a:rPr lang="en-US" sz="630" dirty="0">
+                <a:solidFill>
+                  <a:srgbClr val="1F2937"/>
+                </a:solidFill>
+                <a:latin typeface="Calibri" pitchFamily="34" charset="0"/>
+                <a:ea typeface="Calibri" pitchFamily="34" charset="-122"/>
+                <a:cs typeface="Calibri" pitchFamily="34" charset="-120"/>
+              </a:rPr>
+              <a:t> — to make sure that ₹60,700 goes to the right course.</a:t>
             </a:r>
             <a:endParaRPr lang="en-US" sz="630" dirty="0"/>
           </a:p>

</xml_diff>